<commit_message>
Apply LedWave visual identity: official logo, brand palette, LED dot motif
Decks now use the official logo on light layouts, the logo's gray and the
cyan-to-magenta LED gradient; workbooks use the same palette. CLAUDE.md
records the rule to always use the official logo.

Co-Authored-By: Claude Opus 5.5 <noreply@anthropic.com>
Claude-Session: https://claude.ai/code/session_01Ld9Fj63CqEHYrhnAJFn4Xb
</commit_message>
<xml_diff>
--- a/ledwave-comercial/apresentacoes/LedWave_Arenas_Estadios_Academias_e_Esportes.pptx
+++ b/ledwave-comercial/apresentacoes/LedWave_Arenas_Estadios_Academias_e_Esportes.pptx
@@ -120,18 +120,18 @@
   <p:extLst>
     <p:ext uri="{521415D9-36F7-43E2-AB2F-B90AF26B5E84}">
       <p14:sectionLst xmlns:p14="http://schemas.microsoft.com/office/powerpoint/2010/main">
-        <p14:section name="Abertura" id="{3d2e97c4-d1e0-72b6-28a7-2418b7e19c81}">
+        <p14:section name="Abertura" id="{c8a6002f-12cc-8cf2-5141-d5c32eb99b98}">
           <p14:sldIdLst>
             <p14:sldId id="256"/>
             <p14:sldId id="257"/>
           </p14:sldIdLst>
         </p14:section>
-        <p14:section name="O seu cenário" id="{5b3bc8fd-a38b-5620-5066-72ff9ca290ca}">
+        <p14:section name="O seu cenário" id="{4ce1be5c-0336-37af-4434-34c6095d3166}">
           <p14:sldIdLst>
             <p14:sldId id="258"/>
           </p14:sldIdLst>
         </p14:section>
-        <p14:section name="LedWave" id="{69587496-0ba6-4f45-82c5-462e3ca32ac7}">
+        <p14:section name="LedWave" id="{541f7426-cf96-eff4-4329-296e34c7f7a8}">
           <p14:sldIdLst>
             <p14:sldId id="259"/>
             <p14:sldId id="260"/>
@@ -140,20 +140,20 @@
             <p14:sldId id="263"/>
           </p14:sldIdLst>
         </p14:section>
-        <p14:section name="Por que digitalizar" id="{51e37180-bcae-461d-0e19-4445c9b86be2}">
+        <p14:section name="Por que digitalizar" id="{360aeff5-2ff6-4b9d-5931-24e5f77cb88b}">
           <p14:sldIdLst>
             <p14:sldId id="264"/>
             <p14:sldId id="265"/>
           </p14:sldIdLst>
         </p14:section>
-        <p14:section name="Ganhos e solução" id="{66f69516-a661-cd8d-2f19-701a0b1ac7c8}">
+        <p14:section name="Ganhos e solução" id="{6b339625-1d3a-74e5-f355-30cb7a338fe6}">
           <p14:sldIdLst>
             <p14:sldId id="266"/>
             <p14:sldId id="267"/>
             <p14:sldId id="268"/>
           </p14:sldIdLst>
         </p14:section>
-        <p14:section name="Próximo passo" id="{8f572320-4d85-072d-6f68-63d8a9e583af}">
+        <p14:section name="Próximo passo" id="{96545665-1221-80a0-2cd6-362d385477e3}">
           <p14:sldIdLst>
             <p14:sldId id="269"/>
           </p14:sldIdLst>
@@ -1802,7 +1802,7 @@
     <p:bg>
       <p:bgPr>
         <a:solidFill>
-          <a:srgbClr val="140C2E"/>
+          <a:srgbClr val="FFFFFF"/>
         </a:solidFill>
       </p:bgPr>
     </p:bg>
@@ -1820,54 +1820,66 @@
           <a:chExt cx="0" cy="0"/>
         </a:xfrm>
       </p:grpSpPr>
-      <p:sp>
-        <p:nvSpPr>
-          <p:cNvPr id="2" name="Text 0"/>
-          <p:cNvSpPr txBox="1"/>
-          <p:nvPr/>
-        </p:nvSpPr>
-        <p:spPr>
-          <a:xfrm>
-            <a:off x="548640" y="365760"/>
-            <a:ext cx="2743200" cy="365760"/>
-          </a:xfrm>
-          <a:prstGeom prst="rect">
-            <a:avLst/>
-          </a:prstGeom>
-          <a:noFill/>
-          <a:ln/>
-        </p:spPr>
-        <p:txBody>
-          <a:bodyPr wrap="square" lIns="0" tIns="0" rIns="0" bIns="0" rtlCol="0" anchor="ctr"/>
-          <a:lstStyle/>
-          <a:p>
-            <a:pPr indent="0" marL="0">
-              <a:buNone/>
-            </a:pPr>
-            <a:r>
-              <a:rPr lang="en-US" sz="1600" b="1" dirty="0">
-                <a:solidFill>
-                  <a:srgbClr val="FFFFFF"/>
-                </a:solidFill>
-              </a:rPr>
-              <a:t>LedWave</a:t>
-            </a:r>
-            <a:endParaRPr lang="en-US" sz="1600" dirty="0"/>
-          </a:p>
-        </p:txBody>
-      </p:sp>
-      <p:sp>
-        <p:nvSpPr>
-          <p:cNvPr id="3" name="Text 1"/>
+      <p:pic>
+        <p:nvPicPr>
+          <p:cNvPr id="2" name="Image 0" descr="/tmp/claude-0/-home-user-Treino/88533c10-46fb-551a-b2bc-454e1913f5b1/scratchpad/build/assets/logo-ledwave.png">    </p:cNvPr>
+          <p:cNvPicPr>
+            <a:picLocks noChangeAspect="1"/>
+          </p:cNvPicPr>
+          <p:nvPr/>
+        </p:nvPicPr>
+        <p:blipFill>
+          <a:blip r:embed="rId1"/>
+          <a:stretch>
+            <a:fillRect/>
+          </a:stretch>
+        </p:blipFill>
+        <p:spPr>
+          <a:xfrm>
+            <a:off x="548640" y="411480"/>
+            <a:ext cx="2743200" cy="939769"/>
+          </a:xfrm>
+          <a:prstGeom prst="rect">
+            <a:avLst/>
+          </a:prstGeom>
+        </p:spPr>
+      </p:pic>
+      <p:pic>
+        <p:nvPicPr>
+          <p:cNvPr id="3" name="Image 1" descr="/tmp/claude-0/-home-user-Treino/88533c10-46fb-551a-b2bc-454e1913f5b1/scratchpad/build/assets/pixels-capa.png">    </p:cNvPr>
+          <p:cNvPicPr>
+            <a:picLocks noChangeAspect="1"/>
+          </p:cNvPicPr>
+          <p:nvPr/>
+        </p:nvPicPr>
+        <p:blipFill>
+          <a:blip r:embed="rId2"/>
+          <a:stretch>
+            <a:fillRect/>
+          </a:stretch>
+        </p:blipFill>
+        <p:spPr>
+          <a:xfrm>
+            <a:off x="7863840" y="914400"/>
+            <a:ext cx="3904488" cy="4572000"/>
+          </a:xfrm>
+          <a:prstGeom prst="rect">
+            <a:avLst/>
+          </a:prstGeom>
+        </p:spPr>
+      </p:pic>
+      <p:sp>
+        <p:nvSpPr>
+          <p:cNvPr id="4" name="Text 0"/>
           <p:cNvSpPr/>
           <p:nvPr>
-            <p:ph idx="101" type="title" hasCustomPrompt="1"/>
+            <p:ph idx="102" type="title" hasCustomPrompt="1"/>
           </p:nvPr>
         </p:nvSpPr>
         <p:spPr>
           <a:xfrm>
             <a:off x="548640" y="2103120"/>
-            <a:ext cx="6949440" cy="1737360"/>
+            <a:ext cx="6675120" cy="1737360"/>
           </a:xfrm>
           <a:prstGeom prst="rect">
             <a:avLst/>
@@ -1882,7 +1894,7 @@
               <a:buNone/>
               <a:defRPr lang="en-US" sz="4000" b="1" dirty="0">
                 <a:solidFill>
-                  <a:schemeClr val="bg1"/>
+                  <a:schemeClr val="tx1"/>
                 </a:solidFill>
               </a:defRPr>
             </a:lvl1pPr>
@@ -1897,16 +1909,16 @@
       </p:sp>
       <p:sp>
         <p:nvSpPr>
-          <p:cNvPr id="4" name="Text 1"/>
+          <p:cNvPr id="5" name="Text 0"/>
           <p:cNvSpPr/>
           <p:nvPr>
-            <p:ph idx="102" type="body" hasCustomPrompt="1"/>
+            <p:ph idx="103" type="body" hasCustomPrompt="1"/>
           </p:nvPr>
         </p:nvSpPr>
         <p:spPr>
           <a:xfrm>
             <a:off x="548640" y="3977640"/>
-            <a:ext cx="6949440" cy="1097280"/>
+            <a:ext cx="6675120" cy="1097280"/>
           </a:xfrm>
           <a:prstGeom prst="rect">
             <a:avLst/>
@@ -1921,7 +1933,7 @@
               <a:buNone/>
               <a:defRPr lang="en-US" sz="2000" dirty="0">
                 <a:solidFill>
-                  <a:srgbClr val="D9D2F0"/>
+                  <a:schemeClr val="tx2"/>
                 </a:solidFill>
               </a:defRPr>
             </a:lvl1pPr>
@@ -1948,7 +1960,7 @@
     <p:bg>
       <p:bgPr>
         <a:solidFill>
-          <a:srgbClr val="140C2E"/>
+          <a:srgbClr val="FFFFFF"/>
         </a:solidFill>
       </p:bgPr>
     </p:bg>
@@ -1966,48 +1978,60 @@
           <a:chExt cx="0" cy="0"/>
         </a:xfrm>
       </p:grpSpPr>
-      <p:sp>
-        <p:nvSpPr>
-          <p:cNvPr id="2" name="Text 0"/>
-          <p:cNvSpPr txBox="1"/>
-          <p:nvPr/>
-        </p:nvSpPr>
-        <p:spPr>
-          <a:xfrm>
-            <a:off x="548640" y="365760"/>
-            <a:ext cx="2743200" cy="365760"/>
-          </a:xfrm>
-          <a:prstGeom prst="rect">
-            <a:avLst/>
-          </a:prstGeom>
-          <a:noFill/>
-          <a:ln/>
-        </p:spPr>
-        <p:txBody>
-          <a:bodyPr wrap="square" lIns="0" tIns="0" rIns="0" bIns="0" rtlCol="0" anchor="ctr"/>
-          <a:lstStyle/>
-          <a:p>
-            <a:pPr indent="0" marL="0">
-              <a:buNone/>
-            </a:pPr>
-            <a:r>
-              <a:rPr lang="en-US" sz="1600" b="1" dirty="0">
-                <a:solidFill>
-                  <a:srgbClr val="FFFFFF"/>
-                </a:solidFill>
-              </a:rPr>
-              <a:t>LedWave</a:t>
-            </a:r>
-            <a:endParaRPr lang="en-US" sz="1600" dirty="0"/>
-          </a:p>
-        </p:txBody>
-      </p:sp>
-      <p:sp>
-        <p:nvSpPr>
-          <p:cNvPr id="3" name="Text 1"/>
+      <p:pic>
+        <p:nvPicPr>
+          <p:cNvPr id="2" name="Image 0" descr="/tmp/claude-0/-home-user-Treino/88533c10-46fb-551a-b2bc-454e1913f5b1/scratchpad/build/assets/logo-ledwave.png">    </p:cNvPr>
+          <p:cNvPicPr>
+            <a:picLocks noChangeAspect="1"/>
+          </p:cNvPicPr>
+          <p:nvPr/>
+        </p:nvPicPr>
+        <p:blipFill>
+          <a:blip r:embed="rId1"/>
+          <a:stretch>
+            <a:fillRect/>
+          </a:stretch>
+        </p:blipFill>
+        <p:spPr>
+          <a:xfrm>
+            <a:off x="548640" y="411480"/>
+            <a:ext cx="2194560" cy="751815"/>
+          </a:xfrm>
+          <a:prstGeom prst="rect">
+            <a:avLst/>
+          </a:prstGeom>
+        </p:spPr>
+      </p:pic>
+      <p:pic>
+        <p:nvPicPr>
+          <p:cNvPr id="3" name="Image 1" descr="/tmp/claude-0/-home-user-Treino/88533c10-46fb-551a-b2bc-454e1913f5b1/scratchpad/build/assets/pixels-faixa.png">    </p:cNvPr>
+          <p:cNvPicPr>
+            <a:picLocks noChangeAspect="1"/>
+          </p:cNvPicPr>
+          <p:nvPr/>
+        </p:nvPicPr>
+        <p:blipFill>
+          <a:blip r:embed="rId2"/>
+          <a:stretch>
+            <a:fillRect/>
+          </a:stretch>
+        </p:blipFill>
+        <p:spPr>
+          <a:xfrm>
+            <a:off x="9281160" y="5943600"/>
+            <a:ext cx="2322576" cy="548640"/>
+          </a:xfrm>
+          <a:prstGeom prst="rect">
+            <a:avLst/>
+          </a:prstGeom>
+        </p:spPr>
+      </p:pic>
+      <p:sp>
+        <p:nvSpPr>
+          <p:cNvPr id="4" name="Text 0"/>
           <p:cNvSpPr/>
           <p:nvPr>
-            <p:ph idx="101" type="title" hasCustomPrompt="1"/>
+            <p:ph idx="102" type="title" hasCustomPrompt="1"/>
           </p:nvPr>
         </p:nvSpPr>
         <p:spPr>
@@ -2028,7 +2052,7 @@
               <a:buNone/>
               <a:defRPr lang="en-US" sz="3400" b="1" dirty="0">
                 <a:solidFill>
-                  <a:schemeClr val="bg1"/>
+                  <a:schemeClr val="tx1"/>
                 </a:solidFill>
               </a:defRPr>
             </a:lvl1pPr>
@@ -2043,16 +2067,16 @@
       </p:sp>
       <p:sp>
         <p:nvSpPr>
-          <p:cNvPr id="4" name="Text 1"/>
+          <p:cNvPr id="5" name="Text 0"/>
           <p:cNvSpPr/>
           <p:nvPr>
-            <p:ph idx="102" type="body" hasCustomPrompt="1"/>
+            <p:ph idx="103" type="body" hasCustomPrompt="1"/>
           </p:nvPr>
         </p:nvSpPr>
         <p:spPr>
           <a:xfrm>
             <a:off x="548640" y="4114800"/>
-            <a:ext cx="6949440" cy="1371600"/>
+            <a:ext cx="6949440" cy="1280160"/>
           </a:xfrm>
           <a:prstGeom prst="rect">
             <a:avLst/>
@@ -2067,7 +2091,7 @@
               <a:buNone/>
               <a:defRPr lang="en-US" sz="2000" dirty="0">
                 <a:solidFill>
-                  <a:srgbClr val="D9D2F0"/>
+                  <a:schemeClr val="tx2"/>
                 </a:solidFill>
               </a:defRPr>
             </a:lvl1pPr>
@@ -2094,7 +2118,7 @@
     <p:bg>
       <p:bgPr>
         <a:solidFill>
-          <a:srgbClr val="2B1A63"/>
+          <a:srgbClr val="F2F3F7"/>
         </a:solidFill>
       </p:bgPr>
     </p:bg>
@@ -2112,48 +2136,60 @@
           <a:chExt cx="0" cy="0"/>
         </a:xfrm>
       </p:grpSpPr>
-      <p:sp>
-        <p:nvSpPr>
-          <p:cNvPr id="2" name="Text 0"/>
-          <p:cNvSpPr txBox="1"/>
-          <p:nvPr/>
-        </p:nvSpPr>
-        <p:spPr>
-          <a:xfrm>
-            <a:off x="548640" y="365760"/>
-            <a:ext cx="2743200" cy="365760"/>
-          </a:xfrm>
-          <a:prstGeom prst="rect">
-            <a:avLst/>
-          </a:prstGeom>
-          <a:noFill/>
-          <a:ln/>
-        </p:spPr>
-        <p:txBody>
-          <a:bodyPr wrap="square" lIns="0" tIns="0" rIns="0" bIns="0" rtlCol="0" anchor="ctr"/>
-          <a:lstStyle/>
-          <a:p>
-            <a:pPr indent="0" marL="0">
-              <a:buNone/>
-            </a:pPr>
-            <a:r>
-              <a:rPr lang="en-US" sz="1600" b="1" dirty="0">
-                <a:solidFill>
-                  <a:srgbClr val="FFFFFF"/>
-                </a:solidFill>
-              </a:rPr>
-              <a:t>LedWave</a:t>
-            </a:r>
-            <a:endParaRPr lang="en-US" sz="1600" dirty="0"/>
-          </a:p>
-        </p:txBody>
-      </p:sp>
-      <p:sp>
-        <p:nvSpPr>
-          <p:cNvPr id="3" name="Text 1"/>
+      <p:pic>
+        <p:nvPicPr>
+          <p:cNvPr id="2" name="Image 0" descr="/tmp/claude-0/-home-user-Treino/88533c10-46fb-551a-b2bc-454e1913f5b1/scratchpad/build/assets/logo-ledwave.png">    </p:cNvPr>
+          <p:cNvPicPr>
+            <a:picLocks noChangeAspect="1"/>
+          </p:cNvPicPr>
+          <p:nvPr/>
+        </p:nvPicPr>
+        <p:blipFill>
+          <a:blip r:embed="rId1"/>
+          <a:stretch>
+            <a:fillRect/>
+          </a:stretch>
+        </p:blipFill>
+        <p:spPr>
+          <a:xfrm>
+            <a:off x="548640" y="411480"/>
+            <a:ext cx="1645920" cy="563862"/>
+          </a:xfrm>
+          <a:prstGeom prst="rect">
+            <a:avLst/>
+          </a:prstGeom>
+        </p:spPr>
+      </p:pic>
+      <p:pic>
+        <p:nvPicPr>
+          <p:cNvPr id="3" name="Image 1" descr="/tmp/claude-0/-home-user-Treino/88533c10-46fb-551a-b2bc-454e1913f5b1/scratchpad/build/assets/pixels-faixa.png">    </p:cNvPr>
+          <p:cNvPicPr>
+            <a:picLocks noChangeAspect="1"/>
+          </p:cNvPicPr>
+          <p:nvPr/>
+        </p:nvPicPr>
+        <p:blipFill>
+          <a:blip r:embed="rId2"/>
+          <a:stretch>
+            <a:fillRect/>
+          </a:stretch>
+        </p:blipFill>
+        <p:spPr>
+          <a:xfrm>
+            <a:off x="9098280" y="5897880"/>
+            <a:ext cx="2514600" cy="594360"/>
+          </a:xfrm>
+          <a:prstGeom prst="rect">
+            <a:avLst/>
+          </a:prstGeom>
+        </p:spPr>
+      </p:pic>
+      <p:sp>
+        <p:nvSpPr>
+          <p:cNvPr id="4" name="Text 0"/>
           <p:cNvSpPr/>
           <p:nvPr>
-            <p:ph idx="101" type="title" hasCustomPrompt="1"/>
+            <p:ph idx="102" type="title" hasCustomPrompt="1"/>
           </p:nvPr>
         </p:nvSpPr>
         <p:spPr>
@@ -2189,10 +2225,10 @@
       </p:sp>
       <p:sp>
         <p:nvSpPr>
-          <p:cNvPr id="4" name="Text 1"/>
+          <p:cNvPr id="5" name="Text 0"/>
           <p:cNvSpPr/>
           <p:nvPr>
-            <p:ph idx="102" type="body" hasCustomPrompt="1"/>
+            <p:ph idx="103" type="body" hasCustomPrompt="1"/>
           </p:nvPr>
         </p:nvSpPr>
         <p:spPr>
@@ -2213,7 +2249,7 @@
               <a:buNone/>
               <a:defRPr lang="en-US" sz="3200" b="1" dirty="0">
                 <a:solidFill>
-                  <a:schemeClr val="bg1"/>
+                  <a:schemeClr val="tx1"/>
                 </a:solidFill>
               </a:defRPr>
             </a:lvl1pPr>
@@ -2258,15 +2294,39 @@
           <a:chExt cx="0" cy="0"/>
         </a:xfrm>
       </p:grpSpPr>
-      <p:sp>
-        <p:nvSpPr>
-          <p:cNvPr id="2" name="Text 0"/>
+      <p:pic>
+        <p:nvPicPr>
+          <p:cNvPr id="2" name="Image 0" descr="/tmp/claude-0/-home-user-Treino/88533c10-46fb-551a-b2bc-454e1913f5b1/scratchpad/build/assets/logo-ledwave.png">    </p:cNvPr>
+          <p:cNvPicPr>
+            <a:picLocks noChangeAspect="1"/>
+          </p:cNvPicPr>
+          <p:nvPr/>
+        </p:nvPicPr>
+        <p:blipFill>
+          <a:blip r:embed="rId1"/>
+          <a:stretch>
+            <a:fillRect/>
+          </a:stretch>
+        </p:blipFill>
+        <p:spPr>
+          <a:xfrm>
+            <a:off x="548640" y="6272784"/>
+            <a:ext cx="960120" cy="328919"/>
+          </a:xfrm>
+          <a:prstGeom prst="rect">
+            <a:avLst/>
+          </a:prstGeom>
+        </p:spPr>
+      </p:pic>
+      <p:sp>
+        <p:nvSpPr>
+          <p:cNvPr id="3" name="Text 0"/>
           <p:cNvSpPr txBox="1"/>
           <p:nvPr/>
         </p:nvSpPr>
         <p:spPr>
           <a:xfrm>
-            <a:off x="548640" y="6355080"/>
+            <a:off x="1691640" y="6327648"/>
             <a:ext cx="8229600" cy="274320"/>
           </a:xfrm>
           <a:prstGeom prst="rect">
@@ -2285,10 +2345,10 @@
             <a:r>
               <a:rPr lang="en-US" sz="1000" dirty="0">
                 <a:solidFill>
-                  <a:srgbClr val="6B6385"/>
-                </a:solidFill>
-              </a:rPr>
-              <a:t>LedWave  ·  Arenas, Estádios, Academias e Esportes</a:t>
+                  <a:srgbClr val="7A7A7A"/>
+                </a:solidFill>
+              </a:rPr>
+              <a:t>Arenas, Estádios, Academias e Esportes</a:t>
             </a:r>
             <a:endParaRPr lang="en-US" sz="1000" dirty="0"/>
           </a:p>
@@ -2296,10 +2356,10 @@
       </p:sp>
       <p:sp>
         <p:nvSpPr>
-          <p:cNvPr id="3" name="Text 1"/>
+          <p:cNvPr id="4" name="Text 1"/>
           <p:cNvSpPr/>
           <p:nvPr>
-            <p:ph idx="101" type="title" hasCustomPrompt="1"/>
+            <p:ph idx="102" type="title" hasCustomPrompt="1"/>
           </p:nvPr>
         </p:nvSpPr>
         <p:spPr>
@@ -2363,7 +2423,7 @@
             <a:lvl1pPr>
               <a:defRPr sz="1000">
                 <a:solidFill>
-                  <a:srgbClr val="6B6385"/>
+                  <a:srgbClr val="7A7A7A"/>
                 </a:solidFill>
               </a:defRPr>
             </a:lvl1pPr>
@@ -2433,7 +2493,7 @@
             <a:lvl1pPr>
               <a:defRPr sz="1000">
                 <a:solidFill>
-                  <a:srgbClr val="6B6385"/>
+                  <a:srgbClr val="7A7A7A"/>
                 </a:solidFill>
               </a:defRPr>
             </a:lvl1pPr>
@@ -2731,16 +2791,16 @@
       </p:grpSpPr>
       <p:sp>
         <p:nvSpPr>
-          <p:cNvPr id="2" name="Text 1"/>
+          <p:cNvPr id="2" name="Text 0"/>
           <p:cNvSpPr/>
           <p:nvPr>
-            <p:ph idx="101" type="title" hasCustomPrompt="1"/>
+            <p:ph idx="102" type="title" hasCustomPrompt="1"/>
           </p:nvPr>
         </p:nvSpPr>
         <p:spPr>
           <a:xfrm>
             <a:off x="548640" y="2103120"/>
-            <a:ext cx="6949440" cy="1737360"/>
+            <a:ext cx="6675120" cy="1737360"/>
           </a:xfrm>
           <a:prstGeom prst="rect">
             <a:avLst/>
@@ -2758,7 +2818,7 @@
             <a:r>
               <a:rPr lang="en-US" sz="4000" b="1" dirty="0">
                 <a:solidFill>
-                  <a:schemeClr val="bg1"/>
+                  <a:schemeClr val="tx1"/>
                 </a:solidFill>
               </a:rPr>
               <a:t>Arenas, Estádios, Academias e Esportes</a:t>
@@ -2769,16 +2829,16 @@
       </p:sp>
       <p:sp>
         <p:nvSpPr>
-          <p:cNvPr id="3" name="Text 1"/>
+          <p:cNvPr id="3" name="Text 0"/>
           <p:cNvSpPr/>
           <p:nvPr>
-            <p:ph idx="102" type="body" hasCustomPrompt="1"/>
+            <p:ph idx="103" type="body" hasCustomPrompt="1"/>
           </p:nvPr>
         </p:nvSpPr>
         <p:spPr>
           <a:xfrm>
             <a:off x="548640" y="3977640"/>
-            <a:ext cx="6949440" cy="1097280"/>
+            <a:ext cx="6675120" cy="1097280"/>
           </a:xfrm>
           <a:prstGeom prst="rect">
             <a:avLst/>
@@ -2796,7 +2856,7 @@
             <a:r>
               <a:rPr lang="en-US" sz="2000" dirty="0">
                 <a:solidFill>
-                  <a:srgbClr val="D9D2F0"/>
+                  <a:schemeClr val="tx2"/>
                 </a:solidFill>
               </a:rPr>
               <a:t>Placa estática vende uma marca. LED vende o jogo inteiro.</a:t>
@@ -2832,7 +2892,7 @@
             <a:r>
               <a:rPr lang="en-US" sz="1400" dirty="0">
                 <a:solidFill>
-                  <a:srgbClr val="B8AED8"/>
+                  <a:srgbClr val="7A7A7A"/>
                 </a:solidFill>
               </a:rPr>
               <a:t>Proposta para [Nome do cliente]  ·  [Data]</a:t>
@@ -2849,14 +2909,14 @@
         </p:nvSpPr>
         <p:spPr>
           <a:xfrm>
-            <a:off x="8412480" y="1737360"/>
-            <a:ext cx="3017520" cy="3017520"/>
+            <a:off x="7360920" y="4160520"/>
+            <a:ext cx="1645920" cy="1645920"/>
           </a:xfrm>
           <a:prstGeom prst="ellipse">
             <a:avLst/>
           </a:prstGeom>
           <a:solidFill>
-            <a:srgbClr val="E0218A"/>
+            <a:srgbClr val="5F5F5F"/>
           </a:solidFill>
           <a:ln/>
         </p:spPr>
@@ -2877,8 +2937,8 @@
         </p:blipFill>
         <p:spPr>
           <a:xfrm>
-            <a:off x="9166860" y="2491740"/>
-            <a:ext cx="1508760" cy="1508760"/>
+            <a:off x="7772400" y="4572000"/>
+            <a:ext cx="822960" cy="822960"/>
           </a:xfrm>
           <a:prstGeom prst="rect">
             <a:avLst/>
@@ -2915,7 +2975,7 @@
           <p:cNvPr id="2" name="Text 1"/>
           <p:cNvSpPr/>
           <p:nvPr>
-            <p:ph idx="101" type="title" hasCustomPrompt="1"/>
+            <p:ph idx="102" type="title" hasCustomPrompt="1"/>
           </p:nvPr>
         </p:nvSpPr>
         <p:spPr>
@@ -3041,7 +3101,7 @@
           </a:solidFill>
           <a:ln w="19050">
             <a:solidFill>
-              <a:srgbClr val="8B5CF6"/>
+              <a:srgbClr val="658DFF"/>
             </a:solidFill>
             <a:prstDash val="dash"/>
           </a:ln>
@@ -3062,7 +3122,7 @@
             <a:avLst/>
           </a:prstGeom>
           <a:solidFill>
-            <a:srgbClr val="8B5CF6"/>
+            <a:srgbClr val="658DFF"/>
           </a:solidFill>
           <a:ln/>
         </p:spPr>
@@ -3171,7 +3231,7 @@
             <a:lvl1pPr>
               <a:defRPr sz="1000">
                 <a:solidFill>
-                  <a:srgbClr val="6B6385"/>
+                  <a:srgbClr val="7A7A7A"/>
                 </a:solidFill>
               </a:defRPr>
             </a:lvl1pPr>
@@ -3216,7 +3276,7 @@
           <p:cNvPr id="2" name="Text 1"/>
           <p:cNvSpPr/>
           <p:nvPr>
-            <p:ph idx="101" type="title" hasCustomPrompt="1"/>
+            <p:ph idx="102" type="title" hasCustomPrompt="1"/>
           </p:nvPr>
         </p:nvSpPr>
         <p:spPr>
@@ -3286,7 +3346,7 @@
             <a:avLst/>
           </a:prstGeom>
           <a:solidFill>
-            <a:srgbClr val="E0218A"/>
+            <a:srgbClr val="E011FF"/>
           </a:solidFill>
           <a:ln/>
         </p:spPr>
@@ -3424,7 +3484,7 @@
             <a:avLst/>
           </a:prstGeom>
           <a:solidFill>
-            <a:srgbClr val="4F6BFF"/>
+            <a:srgbClr val="8A5CF6"/>
           </a:solidFill>
           <a:ln/>
         </p:spPr>
@@ -3562,7 +3622,7 @@
             <a:avLst/>
           </a:prstGeom>
           <a:solidFill>
-            <a:srgbClr val="8B5CF6"/>
+            <a:srgbClr val="658DFF"/>
           </a:solidFill>
           <a:ln/>
         </p:spPr>
@@ -3693,7 +3753,7 @@
             <a:lvl1pPr>
               <a:defRPr sz="1000">
                 <a:solidFill>
-                  <a:srgbClr val="6B6385"/>
+                  <a:srgbClr val="7A7A7A"/>
                 </a:solidFill>
               </a:defRPr>
             </a:lvl1pPr>
@@ -3738,7 +3798,7 @@
           <p:cNvPr id="2" name="Text 1"/>
           <p:cNvSpPr/>
           <p:nvPr>
-            <p:ph idx="101" type="title" hasCustomPrompt="1"/>
+            <p:ph idx="102" type="title" hasCustomPrompt="1"/>
           </p:nvPr>
         </p:nvSpPr>
         <p:spPr>
@@ -3822,7 +3882,7 @@
             <a:avLst/>
           </a:prstGeom>
           <a:solidFill>
-            <a:srgbClr val="2B1A63"/>
+            <a:srgbClr val="5F5F5F"/>
           </a:solidFill>
           <a:ln/>
         </p:spPr>
@@ -3902,7 +3962,7 @@
             <a:avLst/>
           </a:prstGeom>
           <a:solidFill>
-            <a:srgbClr val="2B1A63"/>
+            <a:srgbClr val="5F5F5F"/>
           </a:solidFill>
           <a:ln/>
         </p:spPr>
@@ -3982,7 +4042,7 @@
             <a:avLst/>
           </a:prstGeom>
           <a:solidFill>
-            <a:srgbClr val="2B1A63"/>
+            <a:srgbClr val="5F5F5F"/>
           </a:solidFill>
           <a:ln/>
         </p:spPr>
@@ -4229,7 +4289,7 @@
             <a:lvl1pPr>
               <a:defRPr sz="1000">
                 <a:solidFill>
-                  <a:srgbClr val="6B6385"/>
+                  <a:srgbClr val="7A7A7A"/>
                 </a:solidFill>
               </a:defRPr>
             </a:lvl1pPr>
@@ -4274,7 +4334,7 @@
           <p:cNvPr id="2" name="Text 1"/>
           <p:cNvSpPr/>
           <p:nvPr>
-            <p:ph idx="101" type="title" hasCustomPrompt="1"/>
+            <p:ph idx="102" type="title" hasCustomPrompt="1"/>
           </p:nvPr>
         </p:nvSpPr>
         <p:spPr>
@@ -4356,7 +4416,7 @@
             <a:r>
               <a:rPr lang="en-US" sz="1800" b="1" dirty="0">
                 <a:solidFill>
-                  <a:schemeClr val="accent1"/>
+                  <a:schemeClr val="accent2"/>
                 </a:solidFill>
               </a:rPr>
               <a:t>Boulevard.Live</a:t>
@@ -4458,7 +4518,7 @@
           </a:solidFill>
           <a:ln w="19050">
             <a:solidFill>
-              <a:srgbClr val="8B5CF6"/>
+              <a:srgbClr val="658DFF"/>
             </a:solidFill>
             <a:prstDash val="dash"/>
           </a:ln>
@@ -4626,7 +4686,7 @@
             <a:lvl1pPr>
               <a:defRPr sz="1000">
                 <a:solidFill>
-                  <a:srgbClr val="6B6385"/>
+                  <a:srgbClr val="7A7A7A"/>
                 </a:solidFill>
               </a:defRPr>
             </a:lvl1pPr>
@@ -4668,10 +4728,10 @@
       </p:grpSpPr>
       <p:sp>
         <p:nvSpPr>
-          <p:cNvPr id="2" name="Text 1"/>
+          <p:cNvPr id="2" name="Text 0"/>
           <p:cNvSpPr/>
           <p:nvPr>
-            <p:ph idx="101" type="title" hasCustomPrompt="1"/>
+            <p:ph idx="102" type="title" hasCustomPrompt="1"/>
           </p:nvPr>
         </p:nvSpPr>
         <p:spPr>
@@ -4695,7 +4755,7 @@
             <a:r>
               <a:rPr lang="en-US" sz="3400" b="1" dirty="0">
                 <a:solidFill>
-                  <a:schemeClr val="bg1"/>
+                  <a:schemeClr val="tx1"/>
                 </a:solidFill>
               </a:rPr>
               <a:t>Placa estática vende uma marca. LED vende o jogo inteiro.</a:t>
@@ -4706,16 +4766,16 @@
       </p:sp>
       <p:sp>
         <p:nvSpPr>
-          <p:cNvPr id="3" name="Text 1"/>
+          <p:cNvPr id="3" name="Text 0"/>
           <p:cNvSpPr/>
           <p:nvPr>
-            <p:ph idx="102" type="body" hasCustomPrompt="1"/>
+            <p:ph idx="103" type="body" hasCustomPrompt="1"/>
           </p:nvPr>
         </p:nvSpPr>
         <p:spPr>
           <a:xfrm>
             <a:off x="548640" y="4114800"/>
-            <a:ext cx="6949440" cy="1371600"/>
+            <a:ext cx="6949440" cy="1280160"/>
           </a:xfrm>
           <a:prstGeom prst="rect">
             <a:avLst/>
@@ -4733,7 +4793,7 @@
             <a:r>
               <a:rPr lang="en-US" sz="2000" dirty="0">
                 <a:solidFill>
-                  <a:srgbClr val="D9D2F0"/>
+                  <a:schemeClr val="tx2"/>
                 </a:solidFill>
               </a:rPr>
               <a:t>Vamos multiplicar a receita do seu espaço sem aumentar um metro?</a:t>
@@ -4759,7 +4819,7 @@
             </a:avLst>
           </a:prstGeom>
           <a:solidFill>
-            <a:schemeClr val="accent1"/>
+            <a:schemeClr val="tx2"/>
           </a:solidFill>
           <a:ln/>
         </p:spPr>
@@ -4791,7 +4851,7 @@
             <a:r>
               <a:rPr lang="en-US" sz="1800" b="1" dirty="0">
                 <a:solidFill>
-                  <a:schemeClr val="bg1"/>
+                  <a:schemeClr val="accent2"/>
                 </a:solidFill>
               </a:rPr>
               <a:t>Próximo passo</a:t>
@@ -4845,7 +4905,7 @@
         <p:spPr>
           <a:xfrm>
             <a:off x="548640" y="6035040"/>
-            <a:ext cx="10972800" cy="365760"/>
+            <a:ext cx="8229600" cy="365760"/>
           </a:xfrm>
           <a:prstGeom prst="rect">
             <a:avLst/>
@@ -4863,7 +4923,7 @@
             <a:r>
               <a:rPr lang="en-US" sz="1400" dirty="0">
                 <a:solidFill>
-                  <a:srgbClr val="B8AED8"/>
+                  <a:srgbClr val="7A7A7A"/>
                 </a:solidFill>
               </a:rPr>
               <a:t>[Nome do executivo]  ·  [Telefone / WhatsApp]  ·  [E-mail]  ·  ledwave.com.br</a:t>
@@ -4899,10 +4959,10 @@
       </p:grpSpPr>
       <p:sp>
         <p:nvSpPr>
-          <p:cNvPr id="2" name="Text 1"/>
+          <p:cNvPr id="2" name="Text 0"/>
           <p:cNvSpPr/>
           <p:nvPr>
-            <p:ph idx="101" type="title" hasCustomPrompt="1"/>
+            <p:ph idx="102" type="title" hasCustomPrompt="1"/>
           </p:nvPr>
         </p:nvSpPr>
         <p:spPr>
@@ -4937,10 +4997,10 @@
       </p:sp>
       <p:sp>
         <p:nvSpPr>
-          <p:cNvPr id="3" name="Text 1"/>
+          <p:cNvPr id="3" name="Text 0"/>
           <p:cNvSpPr/>
           <p:nvPr>
-            <p:ph idx="102" type="body" hasCustomPrompt="1"/>
+            <p:ph idx="103" type="body" hasCustomPrompt="1"/>
           </p:nvPr>
         </p:nvSpPr>
         <p:spPr>
@@ -4964,7 +5024,7 @@
             <a:r>
               <a:rPr lang="en-US" sz="3200" b="1" dirty="0">
                 <a:solidFill>
-                  <a:schemeClr val="bg1"/>
+                  <a:schemeClr val="tx1"/>
                 </a:solidFill>
               </a:rPr>
               <a:t>Quantos patrocinadores cabem em uma placa estática? E em um painel de LED?</a:t>
@@ -4988,7 +5048,7 @@
             <a:avLst/>
           </a:prstGeom>
           <a:solidFill>
-            <a:srgbClr val="E0218A"/>
+            <a:srgbClr val="E011FF"/>
           </a:solidFill>
           <a:ln/>
         </p:spPr>
@@ -5047,7 +5107,7 @@
           <p:cNvPr id="2" name="Text 1"/>
           <p:cNvSpPr/>
           <p:nvPr>
-            <p:ph idx="101" type="title" hasCustomPrompt="1"/>
+            <p:ph idx="102" type="title" hasCustomPrompt="1"/>
           </p:nvPr>
         </p:nvSpPr>
         <p:spPr>
@@ -5117,7 +5177,7 @@
             <a:avLst/>
           </a:prstGeom>
           <a:solidFill>
-            <a:srgbClr val="4F6BFF"/>
+            <a:srgbClr val="658DFF"/>
           </a:solidFill>
           <a:ln/>
         </p:spPr>
@@ -5255,7 +5315,7 @@
             <a:avLst/>
           </a:prstGeom>
           <a:solidFill>
-            <a:srgbClr val="E0218A"/>
+            <a:srgbClr val="E011FF"/>
           </a:solidFill>
           <a:ln/>
         </p:spPr>
@@ -5386,7 +5446,7 @@
             <a:lvl1pPr>
               <a:defRPr sz="1000">
                 <a:solidFill>
-                  <a:srgbClr val="6B6385"/>
+                  <a:srgbClr val="7A7A7A"/>
                 </a:solidFill>
               </a:defRPr>
             </a:lvl1pPr>
@@ -5431,7 +5491,7 @@
           <p:cNvPr id="2" name="Text 1"/>
           <p:cNvSpPr/>
           <p:nvPr>
-            <p:ph idx="101" type="title" hasCustomPrompt="1"/>
+            <p:ph idx="102" type="title" hasCustomPrompt="1"/>
           </p:nvPr>
         </p:nvSpPr>
         <p:spPr>
@@ -5573,7 +5633,7 @@
           <a:noFill/>
           <a:ln w="38100">
             <a:solidFill>
-              <a:srgbClr val="F3F0FA"/>
+              <a:srgbClr val="F2F3F7"/>
             </a:solidFill>
             <a:prstDash val="solid"/>
           </a:ln>
@@ -5997,7 +6057,7 @@
             <a:lvl1pPr>
               <a:defRPr sz="1000">
                 <a:solidFill>
-                  <a:srgbClr val="6B6385"/>
+                  <a:srgbClr val="7A7A7A"/>
                 </a:solidFill>
               </a:defRPr>
             </a:lvl1pPr>
@@ -6042,7 +6102,7 @@
           <p:cNvPr id="2" name="Text 1"/>
           <p:cNvSpPr/>
           <p:nvPr>
-            <p:ph idx="101" type="title" hasCustomPrompt="1"/>
+            <p:ph idx="102" type="title" hasCustomPrompt="1"/>
           </p:nvPr>
         </p:nvSpPr>
         <p:spPr>
@@ -6478,7 +6538,7 @@
             <a:r>
               <a:rPr lang="en-US" sz="1100" dirty="0">
                 <a:solidFill>
-                  <a:srgbClr val="6B6385"/>
+                  <a:srgbClr val="7A7A7A"/>
                 </a:solidFill>
               </a:rPr>
               <a:t>Ranking Exame Negócios em Expansão com dados auditados pela PwC.</a:t>
@@ -6517,7 +6577,7 @@
             <a:lvl1pPr>
               <a:defRPr sz="1000">
                 <a:solidFill>
-                  <a:srgbClr val="6B6385"/>
+                  <a:srgbClr val="7A7A7A"/>
                 </a:solidFill>
               </a:defRPr>
             </a:lvl1pPr>
@@ -6562,7 +6622,7 @@
           <p:cNvPr id="2" name="Text 1"/>
           <p:cNvSpPr/>
           <p:nvPr>
-            <p:ph idx="101" type="title" hasCustomPrompt="1"/>
+            <p:ph idx="102" type="title" hasCustomPrompt="1"/>
           </p:nvPr>
         </p:nvSpPr>
         <p:spPr>
@@ -6610,7 +6670,7 @@
             <a:avLst/>
           </a:prstGeom>
           <a:solidFill>
-            <a:srgbClr val="2B1A63"/>
+            <a:srgbClr val="5F5F5F"/>
           </a:solidFill>
           <a:ln/>
         </p:spPr>
@@ -6750,7 +6810,7 @@
             <a:avLst/>
           </a:prstGeom>
           <a:solidFill>
-            <a:srgbClr val="2B1A63"/>
+            <a:srgbClr val="5F5F5F"/>
           </a:solidFill>
           <a:ln/>
         </p:spPr>
@@ -6890,7 +6950,7 @@
             <a:avLst/>
           </a:prstGeom>
           <a:solidFill>
-            <a:srgbClr val="2B1A63"/>
+            <a:srgbClr val="5F5F5F"/>
           </a:solidFill>
           <a:ln/>
         </p:spPr>
@@ -7030,7 +7090,7 @@
             <a:avLst/>
           </a:prstGeom>
           <a:solidFill>
-            <a:srgbClr val="2B1A63"/>
+            <a:srgbClr val="5F5F5F"/>
           </a:solidFill>
           <a:ln/>
         </p:spPr>
@@ -7170,7 +7230,7 @@
             <a:avLst/>
           </a:prstGeom>
           <a:solidFill>
-            <a:srgbClr val="2B1A63"/>
+            <a:srgbClr val="5F5F5F"/>
           </a:solidFill>
           <a:ln/>
         </p:spPr>
@@ -7370,7 +7430,7 @@
             <a:lvl1pPr>
               <a:defRPr sz="1000">
                 <a:solidFill>
-                  <a:srgbClr val="6B6385"/>
+                  <a:srgbClr val="7A7A7A"/>
                 </a:solidFill>
               </a:defRPr>
             </a:lvl1pPr>
@@ -7415,7 +7475,7 @@
           <p:cNvPr id="2" name="Text 1"/>
           <p:cNvSpPr/>
           <p:nvPr>
-            <p:ph idx="101" type="title" hasCustomPrompt="1"/>
+            <p:ph idx="102" type="title" hasCustomPrompt="1"/>
           </p:nvPr>
         </p:nvSpPr>
         <p:spPr>
@@ -7485,7 +7545,7 @@
             <a:avLst/>
           </a:prstGeom>
           <a:solidFill>
-            <a:srgbClr val="2B1A63"/>
+            <a:srgbClr val="5F5F5F"/>
           </a:solidFill>
           <a:ln/>
         </p:spPr>
@@ -7623,7 +7683,7 @@
             <a:avLst/>
           </a:prstGeom>
           <a:solidFill>
-            <a:srgbClr val="E0218A"/>
+            <a:srgbClr val="E011FF"/>
           </a:solidFill>
           <a:ln/>
         </p:spPr>
@@ -7761,7 +7821,7 @@
             <a:avLst/>
           </a:prstGeom>
           <a:solidFill>
-            <a:srgbClr val="2B1A63"/>
+            <a:srgbClr val="5F5F5F"/>
           </a:solidFill>
           <a:ln/>
         </p:spPr>
@@ -7899,7 +7959,7 @@
             <a:avLst/>
           </a:prstGeom>
           <a:solidFill>
-            <a:srgbClr val="E0218A"/>
+            <a:srgbClr val="E011FF"/>
           </a:solidFill>
           <a:ln/>
         </p:spPr>
@@ -8037,7 +8097,7 @@
             <a:avLst/>
           </a:prstGeom>
           <a:solidFill>
-            <a:srgbClr val="2B1A63"/>
+            <a:srgbClr val="5F5F5F"/>
           </a:solidFill>
           <a:ln/>
         </p:spPr>
@@ -8175,7 +8235,7 @@
             <a:avLst/>
           </a:prstGeom>
           <a:solidFill>
-            <a:srgbClr val="E0218A"/>
+            <a:srgbClr val="E011FF"/>
           </a:solidFill>
           <a:ln/>
         </p:spPr>
@@ -8313,7 +8373,7 @@
             <a:avLst/>
           </a:prstGeom>
           <a:solidFill>
-            <a:srgbClr val="2B1A63"/>
+            <a:srgbClr val="5F5F5F"/>
           </a:solidFill>
           <a:ln/>
         </p:spPr>
@@ -8451,7 +8511,7 @@
             <a:avLst/>
           </a:prstGeom>
           <a:solidFill>
-            <a:srgbClr val="E0218A"/>
+            <a:srgbClr val="E011FF"/>
           </a:solidFill>
           <a:ln/>
         </p:spPr>
@@ -8582,7 +8642,7 @@
             <a:lvl1pPr>
               <a:defRPr sz="1000">
                 <a:solidFill>
-                  <a:srgbClr val="6B6385"/>
+                  <a:srgbClr val="7A7A7A"/>
                 </a:solidFill>
               </a:defRPr>
             </a:lvl1pPr>
@@ -8627,7 +8687,7 @@
           <p:cNvPr id="2" name="Text 1"/>
           <p:cNvSpPr/>
           <p:nvPr>
-            <p:ph idx="101" type="title" hasCustomPrompt="1"/>
+            <p:ph idx="102" type="title" hasCustomPrompt="1"/>
           </p:nvPr>
         </p:nvSpPr>
         <p:spPr>
@@ -9023,7 +9083,7 @@
             <a:avLst/>
           </a:prstGeom>
           <a:solidFill>
-            <a:srgbClr val="2B1A63"/>
+            <a:srgbClr val="5F5F5F"/>
           </a:solidFill>
           <a:ln/>
         </p:spPr>
@@ -9139,7 +9199,7 @@
             <a:avLst/>
           </a:prstGeom>
           <a:solidFill>
-            <a:srgbClr val="2B1A63"/>
+            <a:srgbClr val="5F5F5F"/>
           </a:solidFill>
           <a:ln/>
         </p:spPr>
@@ -9255,7 +9315,7 @@
             <a:avLst/>
           </a:prstGeom>
           <a:solidFill>
-            <a:srgbClr val="2B1A63"/>
+            <a:srgbClr val="5F5F5F"/>
           </a:solidFill>
           <a:ln/>
         </p:spPr>
@@ -9383,7 +9443,7 @@
             <a:r>
               <a:rPr lang="en-US" sz="1100" i="1" dirty="0">
                 <a:solidFill>
-                  <a:srgbClr val="6B6385"/>
+                  <a:srgbClr val="7A7A7A"/>
                 </a:solidFill>
               </a:rPr>
               <a:t>Troque os nomes pelos logos oficiais dos clientes antes de enviar o arquivo.</a:t>
@@ -9422,7 +9482,7 @@
             <a:lvl1pPr>
               <a:defRPr sz="1000">
                 <a:solidFill>
-                  <a:srgbClr val="6B6385"/>
+                  <a:srgbClr val="7A7A7A"/>
                 </a:solidFill>
               </a:defRPr>
             </a:lvl1pPr>
@@ -9464,10 +9524,10 @@
       </p:grpSpPr>
       <p:sp>
         <p:nvSpPr>
-          <p:cNvPr id="2" name="Text 1"/>
+          <p:cNvPr id="2" name="Text 0"/>
           <p:cNvSpPr/>
           <p:nvPr>
-            <p:ph idx="101" type="title" hasCustomPrompt="1"/>
+            <p:ph idx="102" type="title" hasCustomPrompt="1"/>
           </p:nvPr>
         </p:nvSpPr>
         <p:spPr>
@@ -9502,10 +9562,10 @@
       </p:sp>
       <p:sp>
         <p:nvSpPr>
-          <p:cNvPr id="3" name="Text 1"/>
+          <p:cNvPr id="3" name="Text 0"/>
           <p:cNvSpPr/>
           <p:nvPr>
-            <p:ph idx="102" type="body" hasCustomPrompt="1"/>
+            <p:ph idx="103" type="body" hasCustomPrompt="1"/>
           </p:nvPr>
         </p:nvSpPr>
         <p:spPr>
@@ -9529,7 +9589,7 @@
             <a:r>
               <a:rPr lang="en-US" sz="3200" b="1" dirty="0">
                 <a:solidFill>
-                  <a:schemeClr val="bg1"/>
+                  <a:schemeClr val="tx1"/>
                 </a:solidFill>
               </a:rPr>
               <a:t>Transformar cada jogo, aula e treino em espetáculo e cada metro de placa em receita de patrocínio.</a:t>
@@ -9553,7 +9613,7 @@
             <a:avLst/>
           </a:prstGeom>
           <a:solidFill>
-            <a:srgbClr val="E0218A"/>
+            <a:srgbClr val="E011FF"/>
           </a:solidFill>
           <a:ln/>
         </p:spPr>
@@ -9603,7 +9663,7 @@
           </a:solidFill>
           <a:ln w="19050">
             <a:solidFill>
-              <a:srgbClr val="E0218A"/>
+              <a:srgbClr val="E011FF"/>
             </a:solidFill>
             <a:prstDash val="solid"/>
           </a:ln>
@@ -9666,7 +9726,7 @@
           </a:solidFill>
           <a:ln w="19050">
             <a:solidFill>
-              <a:srgbClr val="E0218A"/>
+              <a:srgbClr val="E011FF"/>
             </a:solidFill>
             <a:prstDash val="solid"/>
           </a:ln>
@@ -9729,7 +9789,7 @@
           </a:solidFill>
           <a:ln w="19050">
             <a:solidFill>
-              <a:srgbClr val="E0218A"/>
+              <a:srgbClr val="E011FF"/>
             </a:solidFill>
             <a:prstDash val="solid"/>
           </a:ln>
@@ -9784,40 +9844,40 @@
   <a:themeElements>
     <a:clrScheme name="LedWave">
       <a:dk1>
-        <a:srgbClr val="140C2E"/>
+        <a:srgbClr val="3D3D3D"/>
       </a:dk1>
       <a:lt1>
         <a:srgbClr val="FFFFFF"/>
       </a:lt1>
       <a:dk2>
-        <a:srgbClr val="2B1A63"/>
+        <a:srgbClr val="5F5F5F"/>
       </a:dk2>
       <a:lt2>
-        <a:srgbClr val="F3F0FA"/>
+        <a:srgbClr val="F2F3F7"/>
       </a:lt2>
       <a:accent1>
-        <a:srgbClr val="E0218A"/>
+        <a:srgbClr val="E011FF"/>
       </a:accent1>
       <a:accent2>
-        <a:srgbClr val="4F6BFF"/>
+        <a:srgbClr val="12D9FF"/>
       </a:accent2>
       <a:accent3>
-        <a:srgbClr val="8B5CF6"/>
+        <a:srgbClr val="658DFF"/>
       </a:accent3>
       <a:accent4>
-        <a:srgbClr val="22C3A6"/>
+        <a:srgbClr val="8A5CF6"/>
       </a:accent4>
       <a:accent5>
-        <a:srgbClr val="FFB020"/>
+        <a:srgbClr val="3EB1FE"/>
       </a:accent5>
       <a:accent6>
-        <a:srgbClr val="6B6385"/>
+        <a:srgbClr val="7A7A7A"/>
       </a:accent6>
       <a:hlink>
-        <a:srgbClr val="4F6BFF"/>
+        <a:srgbClr val="658DFF"/>
       </a:hlink>
       <a:folHlink>
-        <a:srgbClr val="8B5CF6"/>
+        <a:srgbClr val="8A5CF6"/>
       </a:folHlink>
     </a:clrScheme>
     <a:fontScheme name="LedWave">

</xml_diff>